<commit_message>
I have fixed the Patient level splitting, I have now a seperation of all orientations and the creation of the features via the foundation model woks now, based on the orientation. I have tested it with 6 ID´s per group
</commit_message>
<xml_diff>
--- a/Alzheimer_Project_Classmates_Introduction.pptx
+++ b/Alzheimer_Project_Classmates_Introduction.pptx
@@ -117,6 +117,35 @@
     </p:ext>
   </p:extLst>
 </p:presentation>
+</file>
+
+<file path=ppt/changesInfos/changesInfo1.xml><?xml version="1.0" encoding="utf-8"?>
+<pc:chgInfo xmlns:a="http://schemas.openxmlformats.org/drawingml/2006/main" xmlns:r="http://schemas.openxmlformats.org/officeDocument/2006/relationships" xmlns:ac="http://schemas.microsoft.com/office/drawing/2013/main/command" xmlns:pc="http://schemas.microsoft.com/office/powerpoint/2013/main/command">
+  <pc:docChgLst>
+    <pc:chgData name="Frederik Johann Dürr" userId="6347c4c7-4dfb-435f-bbb8-4f320924c67f" providerId="ADAL" clId="{10F0F52B-5443-4E75-AABE-D5887994CE65}"/>
+    <pc:docChg chg="modSld">
+      <pc:chgData name="Frederik Johann Dürr" userId="6347c4c7-4dfb-435f-bbb8-4f320924c67f" providerId="ADAL" clId="{10F0F52B-5443-4E75-AABE-D5887994CE65}" dt="2026-10-05T18:37:10.039" v="15" actId="20577"/>
+      <pc:docMkLst>
+        <pc:docMk/>
+      </pc:docMkLst>
+      <pc:sldChg chg="modSp mod">
+        <pc:chgData name="Frederik Johann Dürr" userId="6347c4c7-4dfb-435f-bbb8-4f320924c67f" providerId="ADAL" clId="{10F0F52B-5443-4E75-AABE-D5887994CE65}" dt="2026-10-05T18:37:10.039" v="15" actId="20577"/>
+        <pc:sldMkLst>
+          <pc:docMk/>
+          <pc:sldMk cId="0" sldId="264"/>
+        </pc:sldMkLst>
+        <pc:spChg chg="mod">
+          <ac:chgData name="Frederik Johann Dürr" userId="6347c4c7-4dfb-435f-bbb8-4f320924c67f" providerId="ADAL" clId="{10F0F52B-5443-4E75-AABE-D5887994CE65}" dt="2026-10-05T18:37:10.039" v="15" actId="20577"/>
+          <ac:spMkLst>
+            <pc:docMk/>
+            <pc:sldMk cId="0" sldId="264"/>
+            <ac:spMk id="2" creationId="{00000000-0000-0000-0000-000000000000}"/>
+          </ac:spMkLst>
+        </pc:spChg>
+      </pc:sldChg>
+    </pc:docChg>
+  </pc:docChgLst>
+</pc:chgInfo>
 </file>
 
 <file path=ppt/notesMasters/notesMaster1.xml><?xml version="1.0" encoding="utf-8"?>
@@ -1125,7 +1154,7 @@
           </a:prstGeom>
           <a:extLst>
             <a:ext uri="{C572A759-6A51-4108-AA02-DFA0A04FC94B}">
-              <ma14:wrappingTextBoxFlag xmlns:ma14="http://schemas.microsoft.com/office/mac/drawingml/2011/main" xmlns="" val="0"/>
+              <ma14:wrappingTextBoxFlag xmlns="" xmlns:ma14="http://schemas.microsoft.com/office/mac/drawingml/2011/main" val="0"/>
             </a:ext>
           </a:extLst>
         </p:spPr>
@@ -1203,7 +1232,7 @@
           </a:prstGeom>
           <a:extLst>
             <a:ext uri="{C572A759-6A51-4108-AA02-DFA0A04FC94B}">
-              <ma14:wrappingTextBoxFlag xmlns:ma14="http://schemas.microsoft.com/office/mac/drawingml/2011/main" xmlns="" val="0"/>
+              <ma14:wrappingTextBoxFlag xmlns="" xmlns:ma14="http://schemas.microsoft.com/office/mac/drawingml/2011/main" val="0"/>
             </a:ext>
           </a:extLst>
         </p:spPr>
@@ -2289,7 +2318,7 @@
           </a:prstGeom>
           <a:extLst>
             <a:ext uri="{C572A759-6A51-4108-AA02-DFA0A04FC94B}">
-              <ma14:wrappingTextBoxFlag xmlns:ma14="http://schemas.microsoft.com/office/mac/drawingml/2011/main" xmlns="" val="0"/>
+              <ma14:wrappingTextBoxFlag xmlns="" xmlns:ma14="http://schemas.microsoft.com/office/mac/drawingml/2011/main" val="0"/>
             </a:ext>
           </a:extLst>
         </p:spPr>
@@ -4059,7 +4088,7 @@
           </a:prstGeom>
           <a:extLst>
             <a:ext uri="{C572A759-6A51-4108-AA02-DFA0A04FC94B}">
-              <ma14:wrappingTextBoxFlag xmlns:ma14="http://schemas.microsoft.com/office/mac/drawingml/2011/main" xmlns="" val="0"/>
+              <ma14:wrappingTextBoxFlag xmlns="" xmlns:ma14="http://schemas.microsoft.com/office/mac/drawingml/2011/main" val="0"/>
             </a:ext>
           </a:extLst>
         </p:spPr>
@@ -5613,7 +5642,7 @@
           </a:prstGeom>
           <a:extLst>
             <a:ext uri="{C572A759-6A51-4108-AA02-DFA0A04FC94B}">
-              <ma14:wrappingTextBoxFlag xmlns:ma14="http://schemas.microsoft.com/office/mac/drawingml/2011/main" xmlns="" val="0"/>
+              <ma14:wrappingTextBoxFlag xmlns="" xmlns:ma14="http://schemas.microsoft.com/office/mac/drawingml/2011/main" val="0"/>
             </a:ext>
           </a:extLst>
         </p:spPr>
@@ -6634,7 +6663,7 @@
           </a:prstGeom>
           <a:extLst>
             <a:ext uri="{C572A759-6A51-4108-AA02-DFA0A04FC94B}">
-              <ma14:wrappingTextBoxFlag xmlns:ma14="http://schemas.microsoft.com/office/mac/drawingml/2011/main" xmlns="" val="0"/>
+              <ma14:wrappingTextBoxFlag xmlns="" xmlns:ma14="http://schemas.microsoft.com/office/mac/drawingml/2011/main" val="0"/>
             </a:ext>
           </a:extLst>
         </p:spPr>
@@ -8078,7 +8107,7 @@
           </a:prstGeom>
           <a:extLst>
             <a:ext uri="{C572A759-6A51-4108-AA02-DFA0A04FC94B}">
-              <ma14:wrappingTextBoxFlag xmlns:ma14="http://schemas.microsoft.com/office/mac/drawingml/2011/main" xmlns="" val="0"/>
+              <ma14:wrappingTextBoxFlag xmlns="" xmlns:ma14="http://schemas.microsoft.com/office/mac/drawingml/2011/main" val="0"/>
             </a:ext>
           </a:extLst>
         </p:spPr>
@@ -9306,7 +9335,7 @@
           </a:prstGeom>
           <a:extLst>
             <a:ext uri="{C572A759-6A51-4108-AA02-DFA0A04FC94B}">
-              <ma14:wrappingTextBoxFlag xmlns:ma14="http://schemas.microsoft.com/office/mac/drawingml/2011/main" xmlns="" val="0"/>
+              <ma14:wrappingTextBoxFlag xmlns="" xmlns:ma14="http://schemas.microsoft.com/office/mac/drawingml/2011/main" val="0"/>
             </a:ext>
           </a:extLst>
         </p:spPr>
@@ -10632,7 +10661,7 @@
           </a:prstGeom>
           <a:extLst>
             <a:ext uri="{C572A759-6A51-4108-AA02-DFA0A04FC94B}">
-              <ma14:wrappingTextBoxFlag xmlns:ma14="http://schemas.microsoft.com/office/mac/drawingml/2011/main" xmlns="" val="0"/>
+              <ma14:wrappingTextBoxFlag xmlns="" xmlns:ma14="http://schemas.microsoft.com/office/mac/drawingml/2011/main" val="0"/>
             </a:ext>
           </a:extLst>
         </p:spPr>
@@ -10726,7 +10755,7 @@
                 <a:ea typeface="Aptos Display" pitchFamily="34" charset="-122"/>
                 <a:cs typeface="Aptos Display" pitchFamily="34" charset="-120"/>
               </a:rPr>
-              <a:t>So, what am I actually doing?</a:t>
+              <a:t>So, what are we actually doing?</a:t>
             </a:r>
             <a:endParaRPr lang="en-US" sz="2800" dirty="0"/>
           </a:p>
@@ -11458,7 +11487,7 @@
           </a:prstGeom>
           <a:extLst>
             <a:ext uri="{C572A759-6A51-4108-AA02-DFA0A04FC94B}">
-              <ma14:wrappingTextBoxFlag xmlns:ma14="http://schemas.microsoft.com/office/mac/drawingml/2011/main" xmlns="" val="0"/>
+              <ma14:wrappingTextBoxFlag xmlns="" xmlns:ma14="http://schemas.microsoft.com/office/mac/drawingml/2011/main" val="0"/>
             </a:ext>
           </a:extLst>
         </p:spPr>

</xml_diff>